<commit_message>
Informativa: deck final 2026-06-17 con textos editados
</commit_message>
<xml_diff>
--- a/docs/informativa/outputs/2026-06-17/deck_informativa_2026-06-17.pptx
+++ b/docs/informativa/outputs/2026-06-17/deck_informativa_2026-06-17.pptx
@@ -3495,7 +3495,7 @@
                   <a:srgbClr val="1A3A5C"/>
                 </a:solidFill>
               </a:rPr>
-              <a:t>Un emisor calificado A en Panamá paga aproximadamente 2.70 puntos porcentuales más que uno calificado AAA, sobre el bono del Tesoro USA del mismo plazo. el plazo más caro para emisores A es '3 a 5 años', donde pagan 4.40 puntos sobre el Tesoro USA. el sector Industriales paga 2.93 puntos porcentuales más que Financiero al mismo nivel de calificación.</a:t>
+              <a:t>Un emisor calificado A en PanamÃ¡ paga aproximadamente 2.70 puntos porcentuales mÃ¡s que uno calificado AAA, sobre el bono del Tesoro USA del mismo plazo. el plazo mÃ¡s caro para emisores A es '3 a 5 aÃ±os', donde pagan 4.40 puntos sobre el Tesoro USA. el sector Industriales paga 2.93 puntos porcentuales mÃ¡s que Financiero al mismo nivel de calificaciÃ³n.</a:t>
             </a:r>
           </a:p>
         </p:txBody>
@@ -3645,7 +3645,7 @@
                   <a:srgbClr val="1A3A5C"/>
                 </a:solidFill>
               </a:rPr>
-              <a:t>El bono soberano de Panamá paga en promedio 1.13 puntos porcentuales más que el bono del Tesoro USA del mismo plazo. la curva soberana panameña está creciente: del 4.68% en plazos cortos sube a 5.75% en los plazos más largos (+1.07 puntos). los forwards implícitos sugieren que las tasas panameñas suban de 4.69% en el primer año a 6.11% en el año 5.</a:t>
+              <a:t>El bono soberano de PanamÃ¡ paga en promedio 1.13 puntos porcentuales mÃ¡s que el bono del Tesoro USA del mismo plazo. la curva soberana panameÃ±a estÃ¡ creciente: del 4.68% en plazos cortos sube a 5.75% en los plazos mÃ¡s largos (+1.07 puntos). los forwards implÃ­citos sugieren que las tasas panameÃ±as suban de 4.69% en el primer aÃ±o a 6.11% en el aÃ±o 5.</a:t>
             </a:r>
           </a:p>
         </p:txBody>
@@ -4053,7 +4053,7 @@
                   <a:srgbClr val="1A3A5C"/>
                 </a:solidFill>
               </a:rPr>
-              <a:t>Por qué usamos un modelo combinado en vez de elegir una sola fuente: al juntar lo que dice el mercado de futuros con la regla de la tasa de equilibrio (Taylor), el modelo combinado acierta más. En los últimos 15 años solo 7 de cada 100 meses fue la peor predicción, mientras que el mercado solo lo fue 12 veces y la regla de Taylor sola 82. En la mayoría de los meses (93%) el modelo combinado fue mejor que la peor de las dos fuentes por separado.</a:t>
+              <a:t>Por quÃ© usamos un modelo combinado en vez de elegir una sola fuente: al juntar lo que dice el mercado de futuros con la regla de la tasa de equilibrio (Taylor), el modelo combinado acierta mÃ¡s. En los Ãºltimos 15 aÃ±os solo 7 de cada 100 meses fue la peor predicciÃ³n, mientras que el mercado solo lo fue 12 veces y la regla de Taylor sola 82. En la mayorÃ­a de los meses (93%) el modelo combinado fue mejor que la peor de las dos fuentes por separado.</a:t>
             </a:r>
           </a:p>
         </p:txBody>
@@ -4203,7 +4203,7 @@
                   <a:srgbClr val="1A3A5C"/>
                 </a:solidFill>
               </a:rPr>
-              <a:t>El mercado espera que la Fed mantenga tasas más altas de lo que ella misma proyecta. Para 2028, los miembros de la Fed proyectan en promedio 3.40%, pero el mercado descuenta 3.87%. Cambios vs proyección anterior de la Fed: para 2026 subió 40 centésimas, para 2027 subió 50 centésimas, para 2028 subió 30 centésimas.</a:t>
+              <a:t>El mercado espera que la Fed mantenga tasas mÃ¡s altas de lo que ella misma proyecta. Para 2028, los miembros de la Fed proyectan en promedio 3.40%, pero el mercado descuenta 3.87%. Cambios vs proyecciÃ³n anterior de la Fed: para 2026 subiÃ³ 40 centÃ©simas, para 2027 subiÃ³ 50 centÃ©simas, para 2028 subiÃ³ 30 centÃ©simas.</a:t>
             </a:r>
           </a:p>
         </p:txBody>
@@ -4353,7 +4353,7 @@
                   <a:srgbClr val="1A3A5C"/>
                 </a:solidFill>
               </a:rPr>
-              <a:t>Nuestro modelo combinado proyecta que en los próximos 12 meses la Fed va a mantener las tasas prácticamente sin cambios (+14 centésimas de punto desde el nivel actual de 3.62%). El mercado de futuros descuenta +17 centésimas, la regla de Taylor sugiere +11 centésimas. El sentimiento de noticias sobre bonos del Tesoro largo está pesimista sobre los bonos largos.</a:t>
+              <a:t>Nuestro modelo combinado proyecta que en los prÃ³ximos 12 meses la Fed va a mantener las tasas prÃ¡cticamente sin cambios (+14 centÃ©simas de punto desde el nivel actual de 3.62%). El mercado de futuros descuenta +17 centÃ©simas, la regla de Taylor sugiere +11 centÃ©simas. El sentimiento de noticias sobre bonos del Tesoro largo estÃ¡ pesimista sobre los bonos largos.</a:t>
             </a:r>
           </a:p>
         </p:txBody>
@@ -4503,7 +4503,7 @@
                   <a:srgbClr val="1A3A5C"/>
                 </a:solidFill>
               </a:rPr>
-              <a:t>La curva de tasas del Tesoro USA está casi plana: el bono a 10 años paga apenas 0.38 puntos más que el de 2 años (4.43% vs 4.05%). el mercado no anticipa bajadas importantes de tasas en los próximos 5 años (espera que la Fed mantenga el nivel actual). la inflación esperada baja con el plazo: para los próximos 2 años el mercado descuenta 2.64% anual, pero para los próximos 30 años descuenta 2.28% (la Fed lograría su meta).</a:t>
+              <a:t>La curva de tasas del Tesoro USA estÃ¡ casi plana: el bono a 10 aÃ±os paga apenas 0.38 puntos mÃ¡s que el de 2 aÃ±os (4.43% vs 4.05%). el mercado no anticipa bajadas importantes de tasas en los prÃ³ximos 5 aÃ±os (espera que la Fed mantenga el nivel actual). la inflaciÃ³n esperada baja con el plazo: para los prÃ³ximos 2 aÃ±os el mercado descuenta 2.64% anual, pero para los prÃ³ximos 30 aÃ±os descuenta 2.28% (la Fed lograrÃ­a su meta).</a:t>
             </a:r>
           </a:p>
         </p:txBody>
@@ -4782,7 +4782,7 @@
                   <a:srgbClr val="1A3A5C"/>
                 </a:solidFill>
               </a:rPr>
-              <a:t>Niveles extremos vs los últimos 5 años: el dólar vs yen está en niveles muy altos vs los últimos 5 años (más alto que el 99% de las observaciones recientes).</a:t>
+              <a:t>Niveles extremos vs los Ãºltimos 5 aÃ±os: el dÃ³lar vs yen estÃ¡ en niveles muy altos vs los Ãºltimos 5 aÃ±os (mÃ¡s alto que el 99% de las observaciones recientes).</a:t>
             </a:r>
           </a:p>
         </p:txBody>

</xml_diff>